<commit_message>
devops-hackathon-final: two figures re-measured on 2026-09-24
PY_TESTS 2171 -> 2172 (pytest --collect-only; one test added fixing CI) and
RUNTIME_VERSION 52 -> 54 (preflight check 2: all five READY at v54 after the
revert deployed). REHEARSAL.md speaks the new count. Deck rebuilt and its own
checks passed; the saved file reads 2172 and v54 on slide 9 and neither old
figure anywhere.

Co-Authored-By: Claude Opus 5.5 <noreply@anthropic.com>
</commit_message>
<xml_diff>
--- a/talks/devops-hackathon-final/pitch/TheAgentOrg-Final.pptx
+++ b/talks/devops-hackathon-final/pitch/TheAgentOrg-Final.pptx
@@ -21233,7 +21233,7 @@
                 </a:solidFill>
                 <a:latin typeface="Helvetica Neue"/>
               </a:rPr>
-              <a:t>2171</a:t>
+              <a:t>2172</a:t>
             </a:r>
           </a:p>
         </p:txBody>
@@ -21421,7 +21421,7 @@
                 </a:solidFill>
                 <a:latin typeface="Helvetica Neue"/>
               </a:rPr>
-              <a:t>v52</a:t>
+              <a:t>v54</a:t>
             </a:r>
           </a:p>
         </p:txBody>

</xml_diff>

<commit_message>
finals: slide 12 at v55 -- the scanner fix is deployed
Runtimes redeployed 2026-09-25 with the fix for a credential on an unmarked diff
line: all five READY at 55, preflight OK, check 3 LINES [3, 4] from the deployed
security runtime. Tests re-measured: 2176 across 95 files, 338 web across 26.
Rendered in PowerPoint and read back.

Co-Authored-By: Claude Opus 5.5 <noreply@anthropic.com>
</commit_message>
<xml_diff>
--- a/talks/devops-hackathon-final/pitch/TheAgentOrg-Final.pptx
+++ b/talks/devops-hackathon-final/pitch/TheAgentOrg-Final.pptx
@@ -746,7 +746,7 @@
           <a:lstStyle/>
           <a:p>
             <a:r>
-              <a:t>SAY Two thousand one hundred and seventy-two automated tests across ninety-three files, plus three hundred and thirty-four for the web app. Five agent runtimes, all ready on the same version; a split would mean a half-finished deploy, and we check for it before every demo. It runs in the cloud from a real issue. It is a product, not a script: you sign in, pick a repository, start a run, watch each stage, approve a gate and read what it cost. And it is multi-tenant: each customer's data sits in its own partition, and AWS itself refuses a read of anyone else's, so our code does not have to remember to.</a:t>
+              <a:t>SAY Two thousand one hundred and seventy-six automated tests across ninety-five files, plus three hundred and thirty-eight for the web app. Five agent runtimes, all ready on the same version; a split would mean a half-finished deploy, and we check for it before every demo. It runs in the cloud from a real issue. It is a product, not a script: you sign in, pick a repository, start a run, watch each stage, approve a gate and read what it cost. And it is multi-tenant: each customer's data sits in its own partition, and AWS itself refuses a read of anyone else's, so our code does not have to remember to.</a:t>
             </a:r>
           </a:p>
         </p:txBody>
@@ -7323,7 +7323,7 @@
                 </a:solidFill>
                 <a:latin typeface="Helvetica Neue"/>
               </a:rPr>
-              <a:t>2172</a:t>
+              <a:t>2176</a:t>
             </a:r>
           </a:p>
         </p:txBody>
@@ -7378,7 +7378,7 @@
                 </a:solidFill>
                 <a:latin typeface="Helvetica Neue"/>
               </a:rPr>
-              <a:t>across 93 files</a:t>
+              <a:t>across 95 files</a:t>
             </a:r>
           </a:p>
         </p:txBody>
@@ -7417,7 +7417,7 @@
                 </a:solidFill>
                 <a:latin typeface="Helvetica Neue"/>
               </a:rPr>
-              <a:t>334</a:t>
+              <a:t>338</a:t>
             </a:r>
           </a:p>
         </p:txBody>
@@ -7511,7 +7511,7 @@
                 </a:solidFill>
                 <a:latin typeface="Helvetica Neue"/>
               </a:rPr>
-              <a:t>v54</a:t>
+              <a:t>v55</a:t>
             </a:r>
           </a:p>
         </p:txBody>

</xml_diff>

<commit_message>
finals: the demo is a real ticket -- a vulnerable pin that Trivy blocks
No demo flag and nothing planted: "Pin requests==2.19.0 ..." Rehearsed live on
run #73 (36096705514, 2026-09-25): POISONED false, develop exit 3, trivy high
CVE-2018-18074 >= high; the medium CVEs stay below. The reviewer APPROVED the pin
and the rule blocked it. 81 s from gate1 approval to the block (was 2 min 19 s).

Slide 16 and the agenda say so; the demo plan is rewritten around the ticket;
the rehearsal script and handout carry the ticket text, the timings, run #73 as
the fallback, and one-line answers for the two things the page also shows (the
test-writing agent's canned answer; a wrong model explanation).

Co-Authored-By: Claude Opus 5.5 <noreply@anthropic.com>
</commit_message>
<xml_diff>
--- a/talks/devops-hackathon-final/pitch/TheAgentOrg-Final.pptx
+++ b/talks/devops-hackathon-final/pitch/TheAgentOrg-Final.pptx
@@ -1032,13 +1032,25 @@
           <a:lstStyle/>
           <a:p>
             <a:r>
-              <a:t>SAY Let me show you the half that matters: a ticket that deliberately carries a credential. Watch the line numbers when it blocks.</a:t>
+              <a:t>SAY Let me show you the half that matters. This ticket asks for something that looks reasonable: pin an old version of the requests library for a legacy proxy. Nothing is planted and no demo flag is set. Watch what the reviewer says, and what the scanners say.</a:t>
             </a:r>
           </a:p>
           <a:p/>
           <a:p>
             <a:r>
-              <a:t>IF ASKED — "what are the three cards?" One per scanner, each showing its own worst finding against the threshold. Only gitleaks reached it, so only gitleaks blocks. That comparison is the whole decision, and a run that passes shows it too.</a:t>
+              <a:t>IF ASKED — "what are the three cards?" One per scanner, each showing its own worst finding against the threshold. Only Trivy reached it, with a high-severity CVE; the medium ones stay below the line. That comparison is the whole decision.</a:t>
+            </a:r>
+          </a:p>
+          <a:p/>
+          <a:p>
+            <a:r>
+              <a:t>IF ASKED — "the explanation under the verdict is wrong" It can be: that paragraph is written by the model after the verdict, and it has no say in it. That is exactly why the model does not decide.</a:t>
+            </a:r>
+          </a:p>
+          <a:p/>
+          <a:p>
+            <a:r>
+              <a:t>IF ASKED — "why does the page say a stage used a canned answer?" The agent that writes tests from the ticket did not get an answer from the model this time, so it used its built-in stand-in, and the page says so rather than hiding it. It does not affect the block.</a:t>
             </a:r>
           </a:p>
         </p:txBody>
@@ -13450,7 +13462,7 @@
                 </a:solidFill>
                 <a:latin typeface="Helvetica Neue"/>
               </a:rPr>
-              <a:t>A ticket that deliberately carries a credential. The scanners find it, the run stops at the security stage, and nothing after it runs.</a:t>
+              <a:t>A real ticket: pin an old version of a library for a legacy system. Nothing is planted and no demo flag is set. Trivy finds a known vulnerability, the run stops at the security stage, and nothing after it runs.</a:t>
             </a:r>
           </a:p>
         </p:txBody>
@@ -13489,7 +13501,7 @@
                 </a:solidFill>
                 <a:latin typeface="Helvetica Neue"/>
               </a:rPr>
-              <a:t>Watch the line numbers: the real scanners report lines 3 and 4. The built-in stand-in, used only when a scanner is unavailable, reports 4 and 5, so the pair shows a real scan happened.</a:t>
+              <a:t>Watch the threshold: the high-severity finding stops the run, and the medium ones do not. The same comparison, per scanner, is on the screen.</a:t>
             </a:r>
           </a:p>
         </p:txBody>
@@ -17298,7 +17310,7 @@
                 </a:solidFill>
                 <a:latin typeface="Helvetica Neue"/>
               </a:rPr>
-              <a:t>a ticket that carries a credential, refused</a:t>
+              <a:t>a ticket that pins a vulnerable library, refused</a:t>
             </a:r>
           </a:p>
         </p:txBody>

</xml_diff>

<commit_message>
finals: retrieval is on in production (v56); slide 12 and the notes say so
Verified in the cloud on run #75 (36116159979), no demo flag, runtimes v56: the
saved run records all three knowledge bases read (18 documents, 4 lookups), the
reviewer approved the vulnerable pin, and Trivy blocked it on CVE-2018-18074.
Slide 13's "used by four of the agents" is now true as deployed. Slide 12:
2182 tests across 96 files, v56. The rehearsal script and handout gain the
"is the knowledge base real?" answer.

Co-Authored-By: Claude Opus 5.5 <noreply@anthropic.com>
</commit_message>
<xml_diff>
--- a/talks/devops-hackathon-final/pitch/TheAgentOrg-Final.pptx
+++ b/talks/devops-hackathon-final/pitch/TheAgentOrg-Final.pptx
@@ -746,7 +746,7 @@
           <a:lstStyle/>
           <a:p>
             <a:r>
-              <a:t>SAY Two thousand one hundred and seventy-six automated tests across ninety-five files, plus three hundred and thirty-eight for the web app. Five agent runtimes, all ready on the same version; a split would mean a half-finished deploy, and we check for it before every demo. It runs in the cloud from a real issue. It is a product, not a script: you sign in, pick a repository, start a run, watch each stage, approve a gate and read what it cost. And it is multi-tenant: each customer's data sits in its own partition, and AWS itself refuses a read of anyone else's, so our code does not have to remember to.</a:t>
+              <a:t>SAY Two thousand one hundred and eighty-two automated tests across ninety-six files, plus three hundred and thirty-eight for the web app. Five agent runtimes, all ready on the same version; a split would mean a half-finished deploy, and we check for it before every demo. It runs in the cloud from a real issue. It is a product, not a script: you sign in, pick a repository, start a run, watch each stage, approve a gate and read what it cost. And it is multi-tenant: each customer's data sits in its own partition, and AWS itself refuses a read of anyone else's, so our code does not have to remember to.</a:t>
             </a:r>
           </a:p>
         </p:txBody>
@@ -817,6 +817,12 @@
           <a:p>
             <a:r>
               <a:t>SAY You gave us ten notes in the pre-final, and every row here is an answer that now exists. One in particular. You asked how the scanners' scores turn into a go or no-go, because you doubted the determinism claim, and you were right to. It held for Trivy and Semgrep, which report their own severities. For gitleaks the word "critical" was simply typed where each finding was created: no table, no policy. There is now one scoring table for all three scanners, and the rule for secrets is written down as a policy. Your note produced a real correction, and I would rather say so than claim we were right all along.</a:t>
+            </a:r>
+          </a:p>
+          <a:p/>
+          <a:p>
+            <a:r>
+              <a:t>IF ASKED — "is the knowledge base real?" Yes. Three hand-written knowledge bases: why past changes were sent back, the team's settled conventions, and security advisories. Before answering, four of the agents look up what is relevant, with plain keyword matching, no vector database. Measured: with it, the reviewer caught a change that did not match its ticket 8 times out of 8; without it, 6. It is switched on in the deployed system, and it never touches the security verdict.</a:t>
             </a:r>
           </a:p>
           <a:p/>
@@ -7335,7 +7341,7 @@
                 </a:solidFill>
                 <a:latin typeface="Helvetica Neue"/>
               </a:rPr>
-              <a:t>2176</a:t>
+              <a:t>2182</a:t>
             </a:r>
           </a:p>
         </p:txBody>
@@ -7390,7 +7396,7 @@
                 </a:solidFill>
                 <a:latin typeface="Helvetica Neue"/>
               </a:rPr>
-              <a:t>across 95 files</a:t>
+              <a:t>across 96 files</a:t>
             </a:r>
           </a:p>
         </p:txBody>
@@ -7523,7 +7529,7 @@
                 </a:solidFill>
                 <a:latin typeface="Helvetica Neue"/>
               </a:rPr>
-              <a:t>v55</a:t>
+              <a:t>v56</a:t>
             </a:r>
           </a:p>
         </p:txBody>

</xml_diff>